<commit_message>
Diapos de la partie BDD 2 (Pac-Man) et mise à jour de la partie BDD 1
- presentation/BDD2_metacritic_pacman.pptx (+ PDF) : 21 diapos dans le style
  arcade de la partie 1 (mêmes sprites, police pixel, cadres, barre de
  progression), graphiques natifs calculés depuis BDD_states, notes orales
- BDD1_vgsales_pacman : interface à 9 pages, apport réel de la base 2
  (qualité perçue) sur la diapo de transition ; PDF régénéré
- suppression des anciennes versions BDD1_vgsales.pptx et .pdf

Co-Authored-By: Claude Opus 5.5 <noreply@anthropic.com>
Claude-Session: https://claude.ai/code/session_017cXd1octdAWX1GTPHzeXBF
</commit_message>
<xml_diff>
--- a/presentation/BDD1_vgsales_pacman.pptx
+++ b/presentation/BDD1_vgsales_pacman.pptx
@@ -3839,7 +3839,7 @@
           <a:p>
             <a:r>
               <a:rPr lang="en-US" dirty="0"/>
-              <a:t>Pour conclure ma partie : cette base a des angles morts. Pas de ventes dématérialisées ni mobiles, une année 2016 incomplète, et quelques ventes mal attribuées entre régions. C'est justement pour ça que le client nous a demandé d'ajouter une deuxième base de données, que mes coéquipiers vont vous présenter.</a:t>
+              <a:t>Pour conclure ma partie : cette base a des angles morts. Pas de ventes dématérialisées ni mobiles, une année 2016 incomplète, et quelques ventes mal attribuées entre régions. Et surtout, les ventes disent combien un jeu s'est vendu, pas s'il était bon. C'est ce que mesure la deuxième base demandée par le client, les notes Metacritic, que Mohamed va vous présenter.</a:t>
             </a:r>
             <a:endParaRPr lang="en-US" dirty="0"/>
           </a:p>
@@ -4279,7 +4279,7 @@
           <a:p>
             <a:r>
               <a:rPr lang="en-US" dirty="0"/>
-              <a:t>Le pipeline en cinq étapes : le CSV brut passe par le module de nettoyage, qui produit un jeu propre. On calcule ensuite les indicateurs avancés, puis on restitue tout dans le notebook (24 figures) et dans une interface Streamlit de 8 pages. Point important : le notebook et l'appli utilisent exactement le même code de nettoyage, et un test vérifie qu'ils obtiennent les mêmes données.</a:t>
+              <a:t>Le pipeline en cinq étapes : le CSV brut passe par le module de nettoyage, qui produit un jeu propre. On calcule ensuite les indicateurs avancés, puis on restitue tout dans le notebook (24 figures) et dans une interface Streamlit de 9 pages. Point important : le notebook et l'appli utilisent exactement le même code de nettoyage, et un test vérifie qu'ils obtiennent les mêmes données.</a:t>
             </a:r>
             <a:endParaRPr lang="en-US" dirty="0"/>
           </a:p>
@@ -22333,6 +22333,10 @@
             <a:prstDash val="solid"/>
           </a:ln>
         </p:spPr>
+        <p:txBody>
+          <a:bodyPr/>
+          <a:p/>
+        </p:txBody>
       </p:sp>
       <p:sp>
         <p:nvSpPr>
@@ -22357,6 +22361,10 @@
             <a:prstDash val="solid"/>
           </a:ln>
         </p:spPr>
+        <p:txBody>
+          <a:bodyPr/>
+          <a:p/>
+        </p:txBody>
       </p:sp>
       <p:sp>
         <p:nvSpPr>
@@ -22384,6 +22392,10 @@
             <a:prstDash val="solid"/>
           </a:ln>
         </p:spPr>
+        <p:txBody>
+          <a:bodyPr/>
+          <a:p/>
+        </p:txBody>
       </p:sp>
       <p:sp>
         <p:nvSpPr>
@@ -22408,6 +22420,10 @@
             <a:prstDash val="solid"/>
           </a:ln>
         </p:spPr>
+        <p:txBody>
+          <a:bodyPr/>
+          <a:p/>
+        </p:txBody>
       </p:sp>
       <p:sp>
         <p:nvSpPr>
@@ -22435,6 +22451,10 @@
             <a:prstDash val="solid"/>
           </a:ln>
         </p:spPr>
+        <p:txBody>
+          <a:bodyPr/>
+          <a:p/>
+        </p:txBody>
       </p:sp>
       <p:sp>
         <p:nvSpPr>
@@ -22459,6 +22479,10 @@
             <a:prstDash val="solid"/>
           </a:ln>
         </p:spPr>
+        <p:txBody>
+          <a:bodyPr/>
+          <a:p/>
+        </p:txBody>
       </p:sp>
       <p:pic>
         <p:nvPicPr>
@@ -22613,7 +22637,7 @@
                 <a:ea typeface="Arial" pitchFamily="34" charset="-122"/>
                 <a:cs typeface="Arial" pitchFamily="34" charset="-120"/>
               </a:rPr>
-              <a:t>Interface Streamlit · 8 pages</a:t>
+              <a:t>Interface Streamlit · 9 pages</a:t>
             </a:r>
             <a:endParaRPr lang="en-US" sz="1800" dirty="0"/>
           </a:p>
@@ -24347,6 +24371,10 @@
             <a:prstDash val="solid"/>
           </a:ln>
         </p:spPr>
+        <p:txBody>
+          <a:bodyPr/>
+          <a:p/>
+        </p:txBody>
       </p:sp>
       <p:sp>
         <p:nvSpPr>
@@ -24371,6 +24399,10 @@
             <a:prstDash val="solid"/>
           </a:ln>
         </p:spPr>
+        <p:txBody>
+          <a:bodyPr/>
+          <a:p/>
+        </p:txBody>
       </p:sp>
       <p:pic>
         <p:nvPicPr>
@@ -24728,6 +24760,10 @@
             <a:prstDash val="solid"/>
           </a:ln>
         </p:spPr>
+        <p:txBody>
+          <a:bodyPr/>
+          <a:p/>
+        </p:txBody>
       </p:sp>
       <p:sp>
         <p:nvSpPr>
@@ -24752,6 +24788,10 @@
             <a:prstDash val="solid"/>
           </a:ln>
         </p:spPr>
+        <p:txBody>
+          <a:bodyPr/>
+          <a:p/>
+        </p:txBody>
       </p:sp>
       <p:pic>
         <p:nvPicPr>
@@ -24858,7 +24898,7 @@
                 <a:ea typeface="Arial" pitchFamily="34" charset="-122"/>
                 <a:cs typeface="Arial" pitchFamily="34" charset="-120"/>
               </a:rPr>
-              <a:t>Une deuxième source pour combler ces angles morts, présentée par l'équipe</a:t>
+              <a:t>Les ventes ne disent pas si un jeu est bon : une deuxième source pour le mesurer</a:t>
             </a:r>
             <a:endParaRPr lang="en-US" sz="1500" dirty="0"/>
           </a:p>
@@ -37059,6 +37099,10 @@
           </a:solidFill>
           <a:ln/>
         </p:spPr>
+        <p:txBody>
+          <a:bodyPr/>
+          <a:p/>
+        </p:txBody>
       </p:sp>
       <p:sp>
         <p:nvSpPr>
@@ -37079,6 +37123,10 @@
           </a:solidFill>
           <a:ln/>
         </p:spPr>
+        <p:txBody>
+          <a:bodyPr/>
+          <a:p/>
+        </p:txBody>
       </p:sp>
       <p:sp>
         <p:nvSpPr>
@@ -37099,6 +37147,10 @@
           </a:solidFill>
           <a:ln/>
         </p:spPr>
+        <p:txBody>
+          <a:bodyPr/>
+          <a:p/>
+        </p:txBody>
       </p:sp>
       <p:sp>
         <p:nvSpPr>
@@ -37119,6 +37171,10 @@
           </a:solidFill>
           <a:ln/>
         </p:spPr>
+        <p:txBody>
+          <a:bodyPr/>
+          <a:p/>
+        </p:txBody>
       </p:sp>
       <p:sp>
         <p:nvSpPr>
@@ -37139,6 +37195,10 @@
           </a:solidFill>
           <a:ln/>
         </p:spPr>
+        <p:txBody>
+          <a:bodyPr/>
+          <a:p/>
+        </p:txBody>
       </p:sp>
       <p:sp>
         <p:nvSpPr>
@@ -37159,6 +37219,10 @@
           </a:solidFill>
           <a:ln/>
         </p:spPr>
+        <p:txBody>
+          <a:bodyPr/>
+          <a:p/>
+        </p:txBody>
       </p:sp>
       <p:sp>
         <p:nvSpPr>
@@ -37179,6 +37243,10 @@
           </a:solidFill>
           <a:ln/>
         </p:spPr>
+        <p:txBody>
+          <a:bodyPr/>
+          <a:p/>
+        </p:txBody>
       </p:sp>
       <p:sp>
         <p:nvSpPr>
@@ -37199,6 +37267,10 @@
           </a:solidFill>
           <a:ln/>
         </p:spPr>
+        <p:txBody>
+          <a:bodyPr/>
+          <a:p/>
+        </p:txBody>
       </p:sp>
       <p:sp>
         <p:nvSpPr>
@@ -37219,6 +37291,10 @@
           </a:solidFill>
           <a:ln/>
         </p:spPr>
+        <p:txBody>
+          <a:bodyPr/>
+          <a:p/>
+        </p:txBody>
       </p:sp>
       <p:sp>
         <p:nvSpPr>
@@ -37239,6 +37315,10 @@
           </a:solidFill>
           <a:ln/>
         </p:spPr>
+        <p:txBody>
+          <a:bodyPr/>
+          <a:p/>
+        </p:txBody>
       </p:sp>
       <p:sp>
         <p:nvSpPr>
@@ -37259,6 +37339,10 @@
           </a:solidFill>
           <a:ln/>
         </p:spPr>
+        <p:txBody>
+          <a:bodyPr/>
+          <a:p/>
+        </p:txBody>
       </p:sp>
       <p:sp>
         <p:nvSpPr>
@@ -37279,6 +37363,10 @@
           </a:solidFill>
           <a:ln/>
         </p:spPr>
+        <p:txBody>
+          <a:bodyPr/>
+          <a:p/>
+        </p:txBody>
       </p:sp>
       <p:sp>
         <p:nvSpPr>
@@ -37299,6 +37387,10 @@
           </a:solidFill>
           <a:ln/>
         </p:spPr>
+        <p:txBody>
+          <a:bodyPr/>
+          <a:p/>
+        </p:txBody>
       </p:sp>
       <p:sp>
         <p:nvSpPr>
@@ -37319,6 +37411,10 @@
           </a:solidFill>
           <a:ln/>
         </p:spPr>
+        <p:txBody>
+          <a:bodyPr/>
+          <a:p/>
+        </p:txBody>
       </p:sp>
       <p:sp>
         <p:nvSpPr>
@@ -37339,6 +37435,10 @@
           </a:solidFill>
           <a:ln/>
         </p:spPr>
+        <p:txBody>
+          <a:bodyPr/>
+          <a:p/>
+        </p:txBody>
       </p:sp>
       <p:sp>
         <p:nvSpPr>
@@ -37359,6 +37459,10 @@
           </a:solidFill>
           <a:ln/>
         </p:spPr>
+        <p:txBody>
+          <a:bodyPr/>
+          <a:p/>
+        </p:txBody>
       </p:sp>
       <p:sp>
         <p:nvSpPr>
@@ -37379,6 +37483,10 @@
           </a:solidFill>
           <a:ln/>
         </p:spPr>
+        <p:txBody>
+          <a:bodyPr/>
+          <a:p/>
+        </p:txBody>
       </p:sp>
       <p:sp>
         <p:nvSpPr>
@@ -37399,6 +37507,10 @@
           </a:solidFill>
           <a:ln/>
         </p:spPr>
+        <p:txBody>
+          <a:bodyPr/>
+          <a:p/>
+        </p:txBody>
       </p:sp>
       <p:sp>
         <p:nvSpPr>
@@ -37419,6 +37531,10 @@
           </a:solidFill>
           <a:ln/>
         </p:spPr>
+        <p:txBody>
+          <a:bodyPr/>
+          <a:p/>
+        </p:txBody>
       </p:sp>
       <p:sp>
         <p:nvSpPr>
@@ -37439,6 +37555,10 @@
           </a:solidFill>
           <a:ln/>
         </p:spPr>
+        <p:txBody>
+          <a:bodyPr/>
+          <a:p/>
+        </p:txBody>
       </p:sp>
       <p:sp>
         <p:nvSpPr>
@@ -37459,6 +37579,10 @@
           </a:solidFill>
           <a:ln/>
         </p:spPr>
+        <p:txBody>
+          <a:bodyPr/>
+          <a:p/>
+        </p:txBody>
       </p:sp>
       <p:sp>
         <p:nvSpPr>
@@ -37479,6 +37603,10 @@
           </a:solidFill>
           <a:ln/>
         </p:spPr>
+        <p:txBody>
+          <a:bodyPr/>
+          <a:p/>
+        </p:txBody>
       </p:sp>
       <p:sp>
         <p:nvSpPr>
@@ -37499,6 +37627,10 @@
           </a:solidFill>
           <a:ln/>
         </p:spPr>
+        <p:txBody>
+          <a:bodyPr/>
+          <a:p/>
+        </p:txBody>
       </p:sp>
       <p:sp>
         <p:nvSpPr>
@@ -37519,6 +37651,10 @@
           </a:solidFill>
           <a:ln/>
         </p:spPr>
+        <p:txBody>
+          <a:bodyPr/>
+          <a:p/>
+        </p:txBody>
       </p:sp>
       <p:sp>
         <p:nvSpPr>
@@ -37539,6 +37675,10 @@
           </a:solidFill>
           <a:ln/>
         </p:spPr>
+        <p:txBody>
+          <a:bodyPr/>
+          <a:p/>
+        </p:txBody>
       </p:sp>
       <p:sp>
         <p:nvSpPr>
@@ -37559,6 +37699,10 @@
           </a:solidFill>
           <a:ln/>
         </p:spPr>
+        <p:txBody>
+          <a:bodyPr/>
+          <a:p/>
+        </p:txBody>
       </p:sp>
       <p:sp>
         <p:nvSpPr>
@@ -37579,6 +37723,10 @@
           </a:solidFill>
           <a:ln/>
         </p:spPr>
+        <p:txBody>
+          <a:bodyPr/>
+          <a:p/>
+        </p:txBody>
       </p:sp>
       <p:sp>
         <p:nvSpPr>
@@ -37599,6 +37747,10 @@
           </a:solidFill>
           <a:ln/>
         </p:spPr>
+        <p:txBody>
+          <a:bodyPr/>
+          <a:p/>
+        </p:txBody>
       </p:sp>
       <p:sp>
         <p:nvSpPr>
@@ -37619,6 +37771,10 @@
           </a:solidFill>
           <a:ln/>
         </p:spPr>
+        <p:txBody>
+          <a:bodyPr/>
+          <a:p/>
+        </p:txBody>
       </p:sp>
       <p:sp>
         <p:nvSpPr>
@@ -37639,6 +37795,10 @@
           </a:solidFill>
           <a:ln/>
         </p:spPr>
+        <p:txBody>
+          <a:bodyPr/>
+          <a:p/>
+        </p:txBody>
       </p:sp>
       <p:sp>
         <p:nvSpPr>
@@ -37659,6 +37819,10 @@
           </a:solidFill>
           <a:ln/>
         </p:spPr>
+        <p:txBody>
+          <a:bodyPr/>
+          <a:p/>
+        </p:txBody>
       </p:sp>
       <p:sp>
         <p:nvSpPr>
@@ -37679,6 +37843,10 @@
           </a:solidFill>
           <a:ln/>
         </p:spPr>
+        <p:txBody>
+          <a:bodyPr/>
+          <a:p/>
+        </p:txBody>
       </p:sp>
       <p:sp>
         <p:nvSpPr>
@@ -37699,6 +37867,10 @@
           </a:solidFill>
           <a:ln/>
         </p:spPr>
+        <p:txBody>
+          <a:bodyPr/>
+          <a:p/>
+        </p:txBody>
       </p:sp>
       <p:pic>
         <p:nvPicPr>
@@ -37798,6 +37970,10 @@
             <a:prstDash val="solid"/>
           </a:ln>
         </p:spPr>
+        <p:txBody>
+          <a:bodyPr/>
+          <a:p/>
+        </p:txBody>
       </p:sp>
       <p:sp>
         <p:nvSpPr>
@@ -37822,6 +37998,10 @@
             <a:prstDash val="solid"/>
           </a:ln>
         </p:spPr>
+        <p:txBody>
+          <a:bodyPr/>
+          <a:p/>
+        </p:txBody>
       </p:sp>
       <p:pic>
         <p:nvPicPr>
@@ -38007,6 +38187,10 @@
           </a:solidFill>
           <a:ln/>
         </p:spPr>
+        <p:txBody>
+          <a:bodyPr/>
+          <a:p/>
+        </p:txBody>
       </p:sp>
       <p:sp>
         <p:nvSpPr>
@@ -38027,6 +38211,10 @@
           </a:solidFill>
           <a:ln/>
         </p:spPr>
+        <p:txBody>
+          <a:bodyPr/>
+          <a:p/>
+        </p:txBody>
       </p:sp>
       <p:sp>
         <p:nvSpPr>
@@ -38047,6 +38235,10 @@
           </a:solidFill>
           <a:ln/>
         </p:spPr>
+        <p:txBody>
+          <a:bodyPr/>
+          <a:p/>
+        </p:txBody>
       </p:sp>
       <p:sp>
         <p:nvSpPr>
@@ -38074,6 +38266,10 @@
             <a:prstDash val="solid"/>
           </a:ln>
         </p:spPr>
+        <p:txBody>
+          <a:bodyPr/>
+          <a:p/>
+        </p:txBody>
       </p:sp>
       <p:sp>
         <p:nvSpPr>
@@ -38098,6 +38294,10 @@
             <a:prstDash val="solid"/>
           </a:ln>
         </p:spPr>
+        <p:txBody>
+          <a:bodyPr/>
+          <a:p/>
+        </p:txBody>
       </p:sp>
       <p:pic>
         <p:nvPicPr>
@@ -38283,6 +38483,10 @@
           </a:solidFill>
           <a:ln/>
         </p:spPr>
+        <p:txBody>
+          <a:bodyPr/>
+          <a:p/>
+        </p:txBody>
       </p:sp>
       <p:sp>
         <p:nvSpPr>
@@ -38303,6 +38507,10 @@
           </a:solidFill>
           <a:ln/>
         </p:spPr>
+        <p:txBody>
+          <a:bodyPr/>
+          <a:p/>
+        </p:txBody>
       </p:sp>
       <p:sp>
         <p:nvSpPr>
@@ -38323,6 +38531,10 @@
           </a:solidFill>
           <a:ln/>
         </p:spPr>
+        <p:txBody>
+          <a:bodyPr/>
+          <a:p/>
+        </p:txBody>
       </p:sp>
       <p:sp>
         <p:nvSpPr>
@@ -38350,6 +38562,10 @@
             <a:prstDash val="solid"/>
           </a:ln>
         </p:spPr>
+        <p:txBody>
+          <a:bodyPr/>
+          <a:p/>
+        </p:txBody>
       </p:sp>
       <p:sp>
         <p:nvSpPr>
@@ -38374,6 +38590,10 @@
             <a:prstDash val="solid"/>
           </a:ln>
         </p:spPr>
+        <p:txBody>
+          <a:bodyPr/>
+          <a:p/>
+        </p:txBody>
       </p:sp>
       <p:pic>
         <p:nvPicPr>
@@ -38559,6 +38779,10 @@
           </a:solidFill>
           <a:ln/>
         </p:spPr>
+        <p:txBody>
+          <a:bodyPr/>
+          <a:p/>
+        </p:txBody>
       </p:sp>
       <p:sp>
         <p:nvSpPr>
@@ -38579,6 +38803,10 @@
           </a:solidFill>
           <a:ln/>
         </p:spPr>
+        <p:txBody>
+          <a:bodyPr/>
+          <a:p/>
+        </p:txBody>
       </p:sp>
       <p:sp>
         <p:nvSpPr>
@@ -38599,6 +38827,10 @@
           </a:solidFill>
           <a:ln/>
         </p:spPr>
+        <p:txBody>
+          <a:bodyPr/>
+          <a:p/>
+        </p:txBody>
       </p:sp>
       <p:sp>
         <p:nvSpPr>
@@ -38626,6 +38858,10 @@
             <a:prstDash val="solid"/>
           </a:ln>
         </p:spPr>
+        <p:txBody>
+          <a:bodyPr/>
+          <a:p/>
+        </p:txBody>
       </p:sp>
       <p:sp>
         <p:nvSpPr>
@@ -38650,6 +38886,10 @@
             <a:prstDash val="solid"/>
           </a:ln>
         </p:spPr>
+        <p:txBody>
+          <a:bodyPr/>
+          <a:p/>
+        </p:txBody>
       </p:sp>
       <p:pic>
         <p:nvPicPr>
@@ -38835,6 +39075,10 @@
           </a:solidFill>
           <a:ln/>
         </p:spPr>
+        <p:txBody>
+          <a:bodyPr/>
+          <a:p/>
+        </p:txBody>
       </p:sp>
       <p:sp>
         <p:nvSpPr>
@@ -38855,6 +39099,10 @@
           </a:solidFill>
           <a:ln/>
         </p:spPr>
+        <p:txBody>
+          <a:bodyPr/>
+          <a:p/>
+        </p:txBody>
       </p:sp>
       <p:sp>
         <p:nvSpPr>
@@ -38875,6 +39123,10 @@
           </a:solidFill>
           <a:ln/>
         </p:spPr>
+        <p:txBody>
+          <a:bodyPr/>
+          <a:p/>
+        </p:txBody>
       </p:sp>
       <p:sp>
         <p:nvSpPr>
@@ -38902,6 +39154,10 @@
             <a:prstDash val="solid"/>
           </a:ln>
         </p:spPr>
+        <p:txBody>
+          <a:bodyPr/>
+          <a:p/>
+        </p:txBody>
       </p:sp>
       <p:sp>
         <p:nvSpPr>
@@ -38926,6 +39182,10 @@
             <a:prstDash val="solid"/>
           </a:ln>
         </p:spPr>
+        <p:txBody>
+          <a:bodyPr/>
+          <a:p/>
+        </p:txBody>
       </p:sp>
       <p:pic>
         <p:nvPicPr>
@@ -39086,7 +39346,7 @@
                 <a:ea typeface="Arial" pitchFamily="34" charset="-122"/>
                 <a:cs typeface="Arial" pitchFamily="34" charset="-120"/>
               </a:rPr>
-              <a:t>24 figures · 8 pages</a:t>
+              <a:t>24 figures · 9 pages</a:t>
             </a:r>
             <a:endParaRPr lang="en-US" sz="1300" dirty="0"/>
           </a:p>

</xml_diff>

<commit_message>
Diapos : voix d'équipe (« nous ») sur les diapos et dans les notes
Co-Authored-By: Claude Opus 5.5 <noreply@anthropic.com>
Claude-Session: https://claude.ai/code/session_01TxBE5TjKmjLNN64JhzgtML
</commit_message>
<xml_diff>
--- a/presentation/BDD1_vgsales_pacman.pptx
+++ b/presentation/BDD1_vgsales_pacman.pptx
@@ -3135,7 +3135,7 @@
           <a:p>
             <a:r>
               <a:rPr lang="en-US" dirty="0"/>
-              <a:t>Bonjour. Je présente la première partie du projet : l'analyse de la base vgsales, les ventes mondiales de jeux vidéo de 1980 à 2016. Mes coéquipiers présenteront ensuite la deuxième base de données.</a:t>
+              <a:t>Bonjour. Nous vous présentons notre projet. Première partie : l'analyse de la base vgsales, les ventes mondiales de jeux vidéo de 1980 à 2016. Nous enchaînerons ensuite avec la deuxième base de données.</a:t>
             </a:r>
             <a:endParaRPr lang="en-US" dirty="0"/>
           </a:p>
@@ -3751,7 +3751,7 @@
           <a:p>
             <a:r>
               <a:rPr lang="en-US" dirty="0"/>
-              <a:t>Je passe maintenant à la démonstration de l'interface. Trois choses à montrer : 1) page Market Power Index, changer les poids des composantes et voir le classement bouger ; 2) cliquer sur un jeu pour ouvrir son profil régional (ex. un RPG japonais) ; 3) utiliser les filtres de la barre latérale. Lancer l'appli AVANT la présentation : python run_app.py.</a:t>
+              <a:t>Nous passons maintenant à la démonstration de l'interface. Trois choses à montrer : 1) page Market Power Index, changer les poids des composantes et voir le classement bouger ; 2) cliquer sur un jeu pour ouvrir son profil régional (ex. un RPG japonais) ; 3) utiliser les filtres de la barre latérale. Lancer l'appli AVANT la présentation : python run_app.py.</a:t>
             </a:r>
             <a:endParaRPr lang="en-US" dirty="0"/>
           </a:p>
@@ -3839,7 +3839,7 @@
           <a:p>
             <a:r>
               <a:rPr lang="en-US" dirty="0"/>
-              <a:t>Pour conclure ma partie : cette base a des angles morts. Pas de ventes dématérialisées ni mobiles, une année 2016 incomplète, et quelques ventes mal attribuées entre régions. Et surtout, les ventes disent combien un jeu s'est vendu, pas s'il était bon. C'est ce que mesure la deuxième base demandée par le client, les notes Metacritic, que Mohamed va vous présenter.</a:t>
+              <a:t>Pour conclure cette première partie : cette base a des angles morts. Pas de ventes dématérialisées ni mobiles, une année 2016 incomplète, et quelques ventes mal attribuées entre régions. Et surtout, les ventes disent combien un jeu s'est vendu, pas s'il était bon. C'est ce que mesure la deuxième base demandée par le client, les notes Metacritic, que nous vous présentons maintenant.</a:t>
             </a:r>
             <a:endParaRPr lang="en-US" dirty="0"/>
           </a:p>
@@ -24906,7 +24906,7 @@
       </p:sp>
       <p:pic>
         <p:nvPicPr>
-          <p:cNvPr id="27" name="o26" descr="→ A VOUS !">    </p:cNvPr>
+          <p:cNvPr id="27" name="o26" descr="→ ON CONTINUE !">    </p:cNvPr>
           <p:cNvPicPr>
             <a:picLocks noChangeAspect="1"/>
           </p:cNvPicPr>
@@ -24920,8 +24920,8 @@
         </p:blipFill>
         <p:spPr>
           <a:xfrm>
-            <a:off x="8196453" y="5303520"/>
-            <a:ext cx="1648206" cy="164592"/>
+            <a:off x="7784973" y="5303520"/>
+            <a:ext cx="2471166" cy="164592"/>
           </a:xfrm>
           <a:prstGeom prst="rect">
             <a:avLst/>
@@ -25821,7 +25821,7 @@
       </p:pic>
       <p:pic>
         <p:nvPicPr>
-          <p:cNvPr id="3" name="o2" descr="Le parcours de ma partie">    </p:cNvPr>
+          <p:cNvPr id="3" name="o2" descr="Notre parcours">    </p:cNvPr>
           <p:cNvPicPr>
             <a:picLocks noChangeAspect="1"/>
           </p:cNvPicPr>
@@ -25836,7 +25836,7 @@
         <p:spPr>
           <a:xfrm>
             <a:off x="548640" y="777240"/>
-            <a:ext cx="6583680" cy="274320"/>
+            <a:ext cx="3840480" cy="274320"/>
           </a:xfrm>
           <a:prstGeom prst="rect">
             <a:avLst/>
@@ -27919,7 +27919,7 @@
                 <a:ea typeface="Arial" pitchFamily="34" charset="-122"/>
                 <a:cs typeface="Arial" pitchFamily="34" charset="-120"/>
               </a:rPr>
-              <a:t>Niveau suivant : la BDD 2, présentée par le reste de l'équipe</a:t>
+              <a:t>Niveau suivant : la BDD 2</a:t>
             </a:r>
             <a:endParaRPr lang="en-US" sz="1600" dirty="0"/>
           </a:p>

</xml_diff>